<commit_message>
Rapor ve sunum güncellendi
</commit_message>
<xml_diff>
--- a/Rapor ve Sunum/Sunum.pptx
+++ b/Rapor ve Sunum/Sunum.pptx
@@ -5,7 +5,7 @@
     <p:sldMasterId id="2147483648" r:id="rId1"/>
   </p:sldMasterIdLst>
   <p:notesMasterIdLst>
-    <p:notesMasterId r:id="rId18"/>
+    <p:notesMasterId r:id="rId20"/>
   </p:notesMasterIdLst>
   <p:sldIdLst>
     <p:sldId id="256" r:id="rId2"/>
@@ -23,7 +23,9 @@
     <p:sldId id="268" r:id="rId14"/>
     <p:sldId id="272" r:id="rId15"/>
     <p:sldId id="273" r:id="rId16"/>
-    <p:sldId id="270" r:id="rId17"/>
+    <p:sldId id="274" r:id="rId17"/>
+    <p:sldId id="275" r:id="rId18"/>
+    <p:sldId id="270" r:id="rId19"/>
   </p:sldIdLst>
   <p:sldSz cx="12192000" cy="6858000"/>
   <p:notesSz cx="6858000" cy="9144000"/>
@@ -272,7 +274,7 @@
       </p15:sldGuideLst>
     </p:ext>
     <p:ext uri="GoogleSlidesCustomDataVersion2">
-      <go:slidesCustomData xmlns="" xmlns:mc="http://schemas.openxmlformats.org/markup-compatibility/2006" xmlns:mv="urn:schemas-microsoft-com:mac:vml" xmlns:c="http://schemas.openxmlformats.org/drawingml/2006/chart" xmlns:dgm="http://schemas.openxmlformats.org/drawingml/2006/diagram" xmlns:o="urn:schemas-microsoft-com:office:office" xmlns:v="urn:schemas-microsoft-com:vml" xmlns:pvml="urn:schemas-microsoft-com:office:powerpoint" xmlns:com="http://schemas.openxmlformats.org/drawingml/2006/compatibility" xmlns:p14="http://schemas.microsoft.com/office/powerpoint/2010/main" xmlns:p15="http://schemas.microsoft.com/office/powerpoint/2012/main" xmlns:ahyp="http://schemas.microsoft.com/office/drawing/2018/hyperlinkcolor" xmlns:go="http://customooxmlschemas.google.com/" r:id="rId19" roundtripDataSignature="AMtx7mhj/GYB1ggYKUJP2439A/heVyHS6Q=="/>
+      <go:slidesCustomData xmlns:go="http://customooxmlschemas.google.com/" xmlns:ahyp="http://schemas.microsoft.com/office/drawing/2018/hyperlinkcolor" xmlns:p15="http://schemas.microsoft.com/office/powerpoint/2012/main" xmlns:p14="http://schemas.microsoft.com/office/powerpoint/2010/main" xmlns:com="http://schemas.openxmlformats.org/drawingml/2006/compatibility" xmlns:pvml="urn:schemas-microsoft-com:office:powerpoint" xmlns:v="urn:schemas-microsoft-com:vml" xmlns:o="urn:schemas-microsoft-com:office:office" xmlns:dgm="http://schemas.openxmlformats.org/drawingml/2006/diagram" xmlns:c="http://schemas.openxmlformats.org/drawingml/2006/chart" xmlns:mv="urn:schemas-microsoft-com:mac:vml" xmlns:mc="http://schemas.openxmlformats.org/markup-compatibility/2006" xmlns="" r:id="rId21" roundtripDataSignature="AMtx7mhj/GYB1ggYKUJP2439A/heVyHS6Q=="/>
     </p:ext>
   </p:extLst>
 </p:presentation>
@@ -11509,10 +11511,15 @@
             <p:ph type="body" idx="1"/>
           </p:nvPr>
         </p:nvSpPr>
-        <p:spPr/>
+        <p:spPr>
+          <a:xfrm>
+            <a:off x="838199" y="2713382"/>
+            <a:ext cx="10515599" cy="3687417"/>
+          </a:xfrm>
+        </p:spPr>
         <p:txBody>
           <a:bodyPr>
-            <a:normAutofit/>
+            <a:noAutofit/>
           </a:bodyPr>
           <a:lstStyle/>
           <a:p>
@@ -11520,18 +11527,105 @@
               <a:buNone/>
             </a:pPr>
             <a:r>
+              <a:rPr lang="tr-TR" sz="1600" b="1" dirty="0"/>
+              <a:t>Uygulama Özellikleri</a:t>
+            </a:r>
+          </a:p>
+          <a:p>
+            <a:r>
+              <a:rPr lang="tr-TR" sz="1600" dirty="0"/>
+              <a:t>Gerçek EICAS </a:t>
+            </a:r>
+            <a:r>
+              <a:rPr lang="tr-TR" sz="1600" dirty="0" err="1"/>
+              <a:t>Primary</a:t>
+            </a:r>
+            <a:r>
+              <a:rPr lang="tr-TR" sz="1600" dirty="0"/>
+              <a:t> </a:t>
+            </a:r>
+            <a:r>
+              <a:rPr lang="tr-TR" sz="1600" dirty="0" err="1"/>
+              <a:t>Parameters</a:t>
+            </a:r>
+            <a:r>
+              <a:rPr lang="tr-TR" sz="1600" dirty="0"/>
+              <a:t> </a:t>
+            </a:r>
+            <a:r>
+              <a:rPr lang="tr-TR" sz="1600" dirty="0" err="1"/>
+              <a:t>Display</a:t>
+            </a:r>
+            <a:r>
+              <a:rPr lang="tr-TR" sz="1600" dirty="0"/>
+              <a:t> ile birebir aynı görünüm ve yazı tipi</a:t>
+            </a:r>
+          </a:p>
+          <a:p>
+            <a:r>
+              <a:rPr lang="tr-TR" sz="1600" dirty="0"/>
+              <a:t>Eksponansiyel yumuşatma tekniği ile ataletsel değer değişimleri </a:t>
+            </a:r>
+          </a:p>
+          <a:p>
+            <a:r>
+              <a:rPr lang="tr-TR" sz="1600" dirty="0"/>
+              <a:t>Motor parametrelerini etkileyen arıza simülasyonları</a:t>
+            </a:r>
+          </a:p>
+          <a:p>
+            <a:r>
+              <a:rPr lang="tr-TR" sz="1600" dirty="0"/>
+              <a:t>Birim dönüşümleri</a:t>
+            </a:r>
+          </a:p>
+          <a:p>
+            <a:r>
+              <a:rPr lang="tr-TR" sz="1600" dirty="0"/>
+              <a:t>Dokuz farklı </a:t>
+            </a:r>
+            <a:r>
+              <a:rPr lang="tr-TR" sz="1600"/>
+              <a:t>uçuş modu</a:t>
+            </a:r>
+            <a:endParaRPr lang="tr-TR" sz="1600" dirty="0"/>
+          </a:p>
+          <a:p>
+            <a:r>
+              <a:rPr lang="tr-TR" sz="1600" dirty="0"/>
+              <a:t>Etkileri daha rahat gözlemleyebilmek için sistem çarpanı manipülasyonları</a:t>
+            </a:r>
+          </a:p>
+          <a:p>
+            <a:r>
+              <a:rPr lang="tr-TR" sz="1600" dirty="0"/>
+              <a:t>Uçuş senaryoları oynatabilme ve kolay bir şekilde yeni senaryolar eklemeye uygun kod yapısı</a:t>
+            </a:r>
+          </a:p>
+          <a:p>
+            <a:r>
+              <a:rPr lang="tr-TR" sz="1600" dirty="0"/>
+              <a:t>Farklı tarayıcı ve ekran boyutlarına uyumlu tasarım</a:t>
+            </a:r>
+          </a:p>
+          <a:p>
+            <a:pPr marL="114300" indent="0">
+              <a:buNone/>
+            </a:pPr>
+            <a:r>
+              <a:rPr lang="tr-TR" sz="1600" dirty="0"/>
+              <a:t>Uygulama demosuna </a:t>
+            </a:r>
+            <a:r>
               <a:rPr lang="tr-TR" sz="1600" dirty="0">
                 <a:hlinkClick r:id="rId2"/>
               </a:rPr>
               <a:t>https://acrilot.github.io/EICAS_Uygulama/</a:t>
             </a:r>
-            <a:endParaRPr lang="tr-TR" sz="1600" dirty="0"/>
-          </a:p>
-          <a:p>
-            <a:pPr marL="114300" indent="0">
-              <a:buNone/>
-            </a:pPr>
-            <a:endParaRPr lang="tr-TR" sz="1600" dirty="0"/>
+            <a:r>
+              <a:rPr lang="tr-TR" sz="1600" dirty="0"/>
+              <a:t> linkinden erişilebilir.</a:t>
+            </a:r>
           </a:p>
         </p:txBody>
       </p:sp>
@@ -11549,6 +11643,299 @@
 </file>
 
 <file path=ppt/slides/slide16.xml><?xml version="1.0" encoding="utf-8"?>
+<p:sld xmlns:a="http://schemas.openxmlformats.org/drawingml/2006/main" xmlns:r="http://schemas.openxmlformats.org/officeDocument/2006/relationships" xmlns:p="http://schemas.openxmlformats.org/presentationml/2006/main">
+  <p:cSld>
+    <p:spTree>
+      <p:nvGrpSpPr>
+        <p:cNvPr id="1" name=""/>
+        <p:cNvGrpSpPr/>
+        <p:nvPr/>
+      </p:nvGrpSpPr>
+      <p:grpSpPr>
+        <a:xfrm>
+          <a:off x="0" y="0"/>
+          <a:ext cx="0" cy="0"/>
+          <a:chOff x="0" y="0"/>
+          <a:chExt cx="0" cy="0"/>
+        </a:xfrm>
+      </p:grpSpPr>
+      <p:sp>
+        <p:nvSpPr>
+          <p:cNvPr id="2" name="Başlık 1">
+            <a:extLst>
+              <a:ext uri="{FF2B5EF4-FFF2-40B4-BE49-F238E27FC236}">
+                <a16:creationId xmlns:a16="http://schemas.microsoft.com/office/drawing/2014/main" id="{F639536E-B3C2-F6BD-F5EC-A1B63C5EBE96}"/>
+              </a:ext>
+            </a:extLst>
+          </p:cNvPr>
+          <p:cNvSpPr>
+            <a:spLocks noGrp="1"/>
+          </p:cNvSpPr>
+          <p:nvPr>
+            <p:ph type="title"/>
+          </p:nvPr>
+        </p:nvSpPr>
+        <p:spPr/>
+        <p:txBody>
+          <a:bodyPr/>
+          <a:lstStyle/>
+          <a:p>
+            <a:r>
+              <a:rPr lang="tr-TR" dirty="0"/>
+              <a:t>Zorluklar</a:t>
+            </a:r>
+          </a:p>
+        </p:txBody>
+      </p:sp>
+      <p:sp>
+        <p:nvSpPr>
+          <p:cNvPr id="3" name="Metin Yer Tutucusu 2">
+            <a:extLst>
+              <a:ext uri="{FF2B5EF4-FFF2-40B4-BE49-F238E27FC236}">
+                <a16:creationId xmlns:a16="http://schemas.microsoft.com/office/drawing/2014/main" id="{EED27223-BA79-92AE-1AC3-4EAC750AC543}"/>
+              </a:ext>
+            </a:extLst>
+          </p:cNvPr>
+          <p:cNvSpPr>
+            <a:spLocks noGrp="1"/>
+          </p:cNvSpPr>
+          <p:nvPr>
+            <p:ph type="body" idx="1"/>
+          </p:nvPr>
+        </p:nvSpPr>
+        <p:spPr/>
+        <p:txBody>
+          <a:bodyPr>
+            <a:normAutofit/>
+          </a:bodyPr>
+          <a:lstStyle/>
+          <a:p>
+            <a:pPr marL="114300" indent="0">
+              <a:buNone/>
+            </a:pPr>
+            <a:r>
+              <a:rPr lang="tr-TR" sz="1600" dirty="0"/>
+              <a:t>Uygulamanın geliştirilmesine karşılaşılan ilk zorluk ekranın gerçekte neye benzediği ve nasıl çalıştığıydı. Bunun için internette genel bir tarama yapılmış ancak yeterli sonuçlar bulunamayınca MS Flight Simulator ve DCS World gibi video oyunlarının forumlarında, bu oyunlar için mod geliştiren kişilerin yayımladığı gönderiler incelenerek bilgi kaynakları ve sistemin uygulanışı konusunda fikir edinilmiştir. Ardından internette tedavülden kalkmış veya eğitim amacı ile kullanılan Boeing 737 manuelleri taranmış ve bu kriterlere uygun bir Flight </a:t>
+            </a:r>
+            <a:r>
+              <a:rPr lang="tr-TR" sz="1600" dirty="0" err="1"/>
+              <a:t>Crew</a:t>
+            </a:r>
+            <a:r>
+              <a:rPr lang="tr-TR" sz="1600" dirty="0"/>
+              <a:t> Operations Manual bulunarak bu belge üzerinden hem ekran hakkında oldukça kapsamlı bilgiler edinilmiş hem de ekranın birebir görüntüsü hakkında resmî bir kaynaktan görseller elde edilmiştir. </a:t>
+            </a:r>
+          </a:p>
+        </p:txBody>
+      </p:sp>
+      <p:sp>
+        <p:nvSpPr>
+          <p:cNvPr id="4" name="Metin Yer Tutucusu 3">
+            <a:extLst>
+              <a:ext uri="{FF2B5EF4-FFF2-40B4-BE49-F238E27FC236}">
+                <a16:creationId xmlns:a16="http://schemas.microsoft.com/office/drawing/2014/main" id="{D0006ABF-50ED-B164-01F4-6E5EF31BC406}"/>
+              </a:ext>
+            </a:extLst>
+          </p:cNvPr>
+          <p:cNvSpPr>
+            <a:spLocks noGrp="1"/>
+          </p:cNvSpPr>
+          <p:nvPr>
+            <p:ph type="body" idx="2"/>
+          </p:nvPr>
+        </p:nvSpPr>
+        <p:spPr/>
+        <p:txBody>
+          <a:bodyPr>
+            <a:normAutofit/>
+          </a:bodyPr>
+          <a:lstStyle/>
+          <a:p>
+            <a:pPr marL="114300" indent="0">
+              <a:buNone/>
+            </a:pPr>
+            <a:r>
+              <a:rPr lang="tr-TR" sz="1600" dirty="0"/>
+              <a:t>İkinci zorluk ise bu verilerin çalışan bir uygulamaya dönüştürülmesi aşamasıydı. İnternette daha önce web tabanlı olarak yapılmış buna benzer bir proje bulunmamakta ve bu da başvurulabilecek kaynak sayısını sınırlandırmaktaydı. Var olan birkaç proje ise uygulamaya entegre edilebilir olmaktan uzak şeylerdi. </a:t>
+            </a:r>
+          </a:p>
+        </p:txBody>
+      </p:sp>
+    </p:spTree>
+    <p:extLst>
+      <p:ext uri="{BB962C8B-B14F-4D97-AF65-F5344CB8AC3E}">
+        <p14:creationId xmlns:p14="http://schemas.microsoft.com/office/powerpoint/2010/main" val="1554545655"/>
+      </p:ext>
+    </p:extLst>
+  </p:cSld>
+  <p:clrMapOvr>
+    <a:masterClrMapping/>
+  </p:clrMapOvr>
+</p:sld>
+</file>
+
+<file path=ppt/slides/slide17.xml><?xml version="1.0" encoding="utf-8"?>
+<p:sld xmlns:a="http://schemas.openxmlformats.org/drawingml/2006/main" xmlns:r="http://schemas.openxmlformats.org/officeDocument/2006/relationships" xmlns:p="http://schemas.openxmlformats.org/presentationml/2006/main">
+  <p:cSld>
+    <p:spTree>
+      <p:nvGrpSpPr>
+        <p:cNvPr id="1" name=""/>
+        <p:cNvGrpSpPr/>
+        <p:nvPr/>
+      </p:nvGrpSpPr>
+      <p:grpSpPr>
+        <a:xfrm>
+          <a:off x="0" y="0"/>
+          <a:ext cx="0" cy="0"/>
+          <a:chOff x="0" y="0"/>
+          <a:chExt cx="0" cy="0"/>
+        </a:xfrm>
+      </p:grpSpPr>
+      <p:sp>
+        <p:nvSpPr>
+          <p:cNvPr id="2" name="Başlık 1">
+            <a:extLst>
+              <a:ext uri="{FF2B5EF4-FFF2-40B4-BE49-F238E27FC236}">
+                <a16:creationId xmlns:a16="http://schemas.microsoft.com/office/drawing/2014/main" id="{5BDC4F54-73E3-F3AC-B579-9E26EBDD8099}"/>
+              </a:ext>
+            </a:extLst>
+          </p:cNvPr>
+          <p:cNvSpPr>
+            <a:spLocks noGrp="1"/>
+          </p:cNvSpPr>
+          <p:nvPr>
+            <p:ph type="title"/>
+          </p:nvPr>
+        </p:nvSpPr>
+        <p:spPr/>
+        <p:txBody>
+          <a:bodyPr/>
+          <a:lstStyle/>
+          <a:p>
+            <a:r>
+              <a:rPr lang="tr-TR" dirty="0"/>
+              <a:t>AI Kullanımı</a:t>
+            </a:r>
+          </a:p>
+        </p:txBody>
+      </p:sp>
+      <p:sp>
+        <p:nvSpPr>
+          <p:cNvPr id="3" name="Metin Yer Tutucusu 2">
+            <a:extLst>
+              <a:ext uri="{FF2B5EF4-FFF2-40B4-BE49-F238E27FC236}">
+                <a16:creationId xmlns:a16="http://schemas.microsoft.com/office/drawing/2014/main" id="{6D1666F5-14A4-3831-7E60-6073126C67B5}"/>
+              </a:ext>
+            </a:extLst>
+          </p:cNvPr>
+          <p:cNvSpPr>
+            <a:spLocks noGrp="1"/>
+          </p:cNvSpPr>
+          <p:nvPr>
+            <p:ph type="body" idx="1"/>
+          </p:nvPr>
+        </p:nvSpPr>
+        <p:spPr/>
+        <p:txBody>
+          <a:bodyPr>
+            <a:normAutofit/>
+          </a:bodyPr>
+          <a:lstStyle/>
+          <a:p>
+            <a:pPr marL="114300" indent="0">
+              <a:buNone/>
+            </a:pPr>
+            <a:r>
+              <a:rPr lang="tr-TR" sz="1600" dirty="0"/>
+              <a:t>Aşağıdaki konularda yapay zekadan yardım alınmıştır:</a:t>
+            </a:r>
+          </a:p>
+          <a:p>
+            <a:r>
+              <a:rPr lang="tr-TR" sz="1600" dirty="0"/>
+              <a:t>EICAS ekranı hakkında bilgi toplama, uygun algoritmaların ve matematiksel formüllerin seçimi</a:t>
+            </a:r>
+          </a:p>
+          <a:p>
+            <a:r>
+              <a:rPr lang="tr-TR" sz="1600" dirty="0"/>
+              <a:t>Kullanılan uygulamalar ve diller hakkında bilgi edinme (</a:t>
+            </a:r>
+            <a:r>
+              <a:rPr lang="tr-TR" sz="1600" dirty="0" err="1"/>
+              <a:t>Inkscape</a:t>
+            </a:r>
+            <a:r>
+              <a:rPr lang="tr-TR" sz="1600" dirty="0"/>
+              <a:t>, HTML5, CSS, JavaScript, </a:t>
+            </a:r>
+            <a:r>
+              <a:rPr lang="tr-TR" sz="1600" dirty="0" err="1"/>
+              <a:t>LaTeX</a:t>
+            </a:r>
+            <a:r>
+              <a:rPr lang="tr-TR" sz="1600" dirty="0"/>
+              <a:t>)</a:t>
+            </a:r>
+          </a:p>
+          <a:p>
+            <a:r>
+              <a:rPr lang="tr-TR" sz="1600" dirty="0"/>
+              <a:t>Kod yazımı, optimizasyonu ve değerlendirmesi</a:t>
+            </a:r>
+          </a:p>
+          <a:p>
+            <a:r>
+              <a:rPr lang="tr-TR" sz="1600" dirty="0"/>
+              <a:t>Raporda kullanılan görsel stillerin oluşturulması</a:t>
+            </a:r>
+          </a:p>
+        </p:txBody>
+      </p:sp>
+      <p:pic>
+        <p:nvPicPr>
+          <p:cNvPr id="6" name="Resim 5">
+            <a:extLst>
+              <a:ext uri="{FF2B5EF4-FFF2-40B4-BE49-F238E27FC236}">
+                <a16:creationId xmlns:a16="http://schemas.microsoft.com/office/drawing/2014/main" id="{A3933B4B-B80E-7A73-B40E-F2CA927C88F3}"/>
+              </a:ext>
+            </a:extLst>
+          </p:cNvPr>
+          <p:cNvPicPr>
+            <a:picLocks noChangeAspect="1"/>
+          </p:cNvPicPr>
+          <p:nvPr/>
+        </p:nvPicPr>
+        <p:blipFill>
+          <a:blip r:embed="rId2"/>
+          <a:stretch>
+            <a:fillRect/>
+          </a:stretch>
+        </p:blipFill>
+        <p:spPr>
+          <a:xfrm>
+            <a:off x="7801579" y="0"/>
+            <a:ext cx="4390421" cy="6858000"/>
+          </a:xfrm>
+          <a:prstGeom prst="rect">
+            <a:avLst/>
+          </a:prstGeom>
+        </p:spPr>
+      </p:pic>
+    </p:spTree>
+    <p:extLst>
+      <p:ext uri="{BB962C8B-B14F-4D97-AF65-F5344CB8AC3E}">
+        <p14:creationId xmlns:p14="http://schemas.microsoft.com/office/powerpoint/2010/main" val="138790917"/>
+      </p:ext>
+    </p:extLst>
+  </p:cSld>
+  <p:clrMapOvr>
+    <a:masterClrMapping/>
+  </p:clrMapOvr>
+</p:sld>
+</file>
+
+<file path=ppt/slides/slide18.xml><?xml version="1.0" encoding="utf-8"?>
 <p:sld xmlns:a="http://schemas.openxmlformats.org/drawingml/2006/main" xmlns:r="http://schemas.openxmlformats.org/officeDocument/2006/relationships" xmlns:p="http://schemas.openxmlformats.org/presentationml/2006/main">
   <p:cSld>
     <p:spTree>

</xml_diff>